<commit_message>
edits to README and presentation
</commit_message>
<xml_diff>
--- a/deliverables/project_presentation.pptx
+++ b/deliverables/project_presentation.pptx
@@ -136,7 +136,7 @@
   <pc:docChgLst>
     <pc:chgData name="Skidmore, Ashley (Ashland)" userId="e9632adf-63fc-410d-b7a6-aeefea2bbcdf" providerId="ADAL" clId="{AF9B4E55-D5E8-4675-908F-49E3E051134E}"/>
     <pc:docChg chg="undo custSel addSld delSld modSld">
-      <pc:chgData name="Skidmore, Ashley (Ashland)" userId="e9632adf-63fc-410d-b7a6-aeefea2bbcdf" providerId="ADAL" clId="{AF9B4E55-D5E8-4675-908F-49E3E051134E}" dt="2025-07-06T20:36:16.801" v="1954" actId="207"/>
+      <pc:chgData name="Skidmore, Ashley (Ashland)" userId="e9632adf-63fc-410d-b7a6-aeefea2bbcdf" providerId="ADAL" clId="{AF9B4E55-D5E8-4675-908F-49E3E051134E}" dt="2025-07-06T21:00:23.469" v="1963" actId="20577"/>
       <pc:docMkLst>
         <pc:docMk/>
       </pc:docMkLst>
@@ -188,7 +188,7 @@
         </pc:picChg>
       </pc:sldChg>
       <pc:sldChg chg="delSp modSp new mod">
-        <pc:chgData name="Skidmore, Ashley (Ashland)" userId="e9632adf-63fc-410d-b7a6-aeefea2bbcdf" providerId="ADAL" clId="{AF9B4E55-D5E8-4675-908F-49E3E051134E}" dt="2025-07-06T20:15:30.357" v="97" actId="1036"/>
+        <pc:chgData name="Skidmore, Ashley (Ashland)" userId="e9632adf-63fc-410d-b7a6-aeefea2bbcdf" providerId="ADAL" clId="{AF9B4E55-D5E8-4675-908F-49E3E051134E}" dt="2025-07-06T21:00:23.469" v="1963" actId="20577"/>
         <pc:sldMkLst>
           <pc:docMk/>
           <pc:sldMk cId="1202998437" sldId="258"/>
@@ -202,7 +202,7 @@
           </ac:spMkLst>
         </pc:spChg>
         <pc:spChg chg="mod">
-          <ac:chgData name="Skidmore, Ashley (Ashland)" userId="e9632adf-63fc-410d-b7a6-aeefea2bbcdf" providerId="ADAL" clId="{AF9B4E55-D5E8-4675-908F-49E3E051134E}" dt="2025-07-06T20:15:14.492" v="78" actId="1036"/>
+          <ac:chgData name="Skidmore, Ashley (Ashland)" userId="e9632adf-63fc-410d-b7a6-aeefea2bbcdf" providerId="ADAL" clId="{AF9B4E55-D5E8-4675-908F-49E3E051134E}" dt="2025-07-06T21:00:23.469" v="1963" actId="20577"/>
           <ac:spMkLst>
             <pc:docMk/>
             <pc:sldMk cId="1202998437" sldId="258"/>
@@ -5478,7 +5478,15 @@
           <a:p>
             <a:r>
               <a:rPr lang="en-US" dirty="0"/>
-              <a:t>By analyzing demographic microdata and occupational projections, the project highlights how educational attainment among formerly incarcerated individuals aligns--or fails to align—-with high-demand, high-wage jobs in the state.</a:t>
+              <a:t>By analyzing demographic microdata and occupational projections, the project highlights how educational attainment </a:t>
+            </a:r>
+            <a:r>
+              <a:rPr lang="en-US"/>
+              <a:t>among incarcerated </a:t>
+            </a:r>
+            <a:r>
+              <a:rPr lang="en-US" dirty="0"/>
+              <a:t>individuals aligns--or fails to align—-with high-demand, high-wage jobs in the state.</a:t>
             </a:r>
           </a:p>
           <a:p>

</xml_diff>

<commit_message>
updated presentation files with additional considerations and applications for data
</commit_message>
<xml_diff>
--- a/deliverables/project_presentation.pptx
+++ b/deliverables/project_presentation.pptx
@@ -14,9 +14,11 @@
     <p:sldId id="262" r:id="rId8"/>
     <p:sldId id="263" r:id="rId9"/>
     <p:sldId id="264" r:id="rId10"/>
-    <p:sldId id="265" r:id="rId11"/>
-    <p:sldId id="266" r:id="rId12"/>
+    <p:sldId id="266" r:id="rId11"/>
+    <p:sldId id="265" r:id="rId12"/>
     <p:sldId id="267" r:id="rId13"/>
+    <p:sldId id="269" r:id="rId14"/>
+    <p:sldId id="268" r:id="rId15"/>
   </p:sldIdLst>
   <p:sldSz cx="12192000" cy="6858000"/>
   <p:notesSz cx="6858000" cy="9144000"/>
@@ -126,7 +128,7 @@
 <file path=ppt/revisionInfo.xml><?xml version="1.0" encoding="utf-8"?>
 <p1510:revInfo xmlns:a="http://schemas.openxmlformats.org/drawingml/2006/main" xmlns:r="http://schemas.openxmlformats.org/officeDocument/2006/relationships" xmlns:p1510="http://schemas.microsoft.com/office/powerpoint/2015/10/main">
   <p1510:revLst>
-    <p1510:client id="{AF9B4E55-D5E8-4675-908F-49E3E051134E}" v="21" dt="2025-07-06T20:30:52.302"/>
+    <p1510:client id="{AF9B4E55-D5E8-4675-908F-49E3E051134E}" v="33" dt="2025-07-10T21:51:29.936"/>
   </p1510:revLst>
 </p1510:revInfo>
 </file>
@@ -135,8 +137,8 @@
 <pc:chgInfo xmlns:a="http://schemas.openxmlformats.org/drawingml/2006/main" xmlns:r="http://schemas.openxmlformats.org/officeDocument/2006/relationships" xmlns:ac="http://schemas.microsoft.com/office/drawing/2013/main/command" xmlns:pc="http://schemas.microsoft.com/office/powerpoint/2013/main/command">
   <pc:docChgLst>
     <pc:chgData name="Skidmore, Ashley (Ashland)" userId="e9632adf-63fc-410d-b7a6-aeefea2bbcdf" providerId="ADAL" clId="{AF9B4E55-D5E8-4675-908F-49E3E051134E}"/>
-    <pc:docChg chg="undo custSel addSld delSld modSld">
-      <pc:chgData name="Skidmore, Ashley (Ashland)" userId="e9632adf-63fc-410d-b7a6-aeefea2bbcdf" providerId="ADAL" clId="{AF9B4E55-D5E8-4675-908F-49E3E051134E}" dt="2025-07-06T21:00:23.469" v="1963" actId="20577"/>
+    <pc:docChg chg="undo custSel addSld delSld modSld sldOrd">
+      <pc:chgData name="Skidmore, Ashley (Ashland)" userId="e9632adf-63fc-410d-b7a6-aeefea2bbcdf" providerId="ADAL" clId="{AF9B4E55-D5E8-4675-908F-49E3E051134E}" dt="2025-07-10T21:51:43.990" v="2492" actId="1035"/>
       <pc:docMkLst>
         <pc:docMk/>
       </pc:docMkLst>
@@ -154,14 +156,6 @@
             <ac:spMk id="2" creationId="{EB731451-C8B6-BD65-7012-F64C485AA532}"/>
           </ac:spMkLst>
         </pc:spChg>
-        <pc:spChg chg="add del">
-          <ac:chgData name="Skidmore, Ashley (Ashland)" userId="e9632adf-63fc-410d-b7a6-aeefea2bbcdf" providerId="ADAL" clId="{AF9B4E55-D5E8-4675-908F-49E3E051134E}" dt="2025-07-06T20:13:06.317" v="6" actId="931"/>
-          <ac:spMkLst>
-            <pc:docMk/>
-            <pc:sldMk cId="2112531326" sldId="257"/>
-            <ac:spMk id="3" creationId="{6F3D04D5-173B-297D-3EB3-2B0E742B0B55}"/>
-          </ac:spMkLst>
-        </pc:spChg>
         <pc:spChg chg="mod">
           <ac:chgData name="Skidmore, Ashley (Ashland)" userId="e9632adf-63fc-410d-b7a6-aeefea2bbcdf" providerId="ADAL" clId="{AF9B4E55-D5E8-4675-908F-49E3E051134E}" dt="2025-07-06T20:13:47.861" v="29"/>
           <ac:spMkLst>
@@ -170,14 +164,6 @@
             <ac:spMk id="4" creationId="{1BA58A04-C547-3203-8E4E-B52B6770571F}"/>
           </ac:spMkLst>
         </pc:spChg>
-        <pc:picChg chg="add mod">
-          <ac:chgData name="Skidmore, Ashley (Ashland)" userId="e9632adf-63fc-410d-b7a6-aeefea2bbcdf" providerId="ADAL" clId="{AF9B4E55-D5E8-4675-908F-49E3E051134E}" dt="2025-07-06T20:12:26.335" v="5" actId="931"/>
-          <ac:picMkLst>
-            <pc:docMk/>
-            <pc:sldMk cId="2112531326" sldId="257"/>
-            <ac:picMk id="6" creationId="{E66C4387-F441-8761-9823-2BE6A0B38D3B}"/>
-          </ac:picMkLst>
-        </pc:picChg>
         <pc:picChg chg="add mod">
           <ac:chgData name="Skidmore, Ashley (Ashland)" userId="e9632adf-63fc-410d-b7a6-aeefea2bbcdf" providerId="ADAL" clId="{AF9B4E55-D5E8-4675-908F-49E3E051134E}" dt="2025-07-06T20:13:20.984" v="10" actId="962"/>
           <ac:picMkLst>
@@ -209,14 +195,6 @@
             <ac:spMk id="3" creationId="{543991B8-41C2-43C2-7D15-D1DFFA45CB65}"/>
           </ac:spMkLst>
         </pc:spChg>
-        <pc:spChg chg="del">
-          <ac:chgData name="Skidmore, Ashley (Ashland)" userId="e9632adf-63fc-410d-b7a6-aeefea2bbcdf" providerId="ADAL" clId="{AF9B4E55-D5E8-4675-908F-49E3E051134E}" dt="2025-07-06T20:15:07.358" v="51" actId="478"/>
-          <ac:spMkLst>
-            <pc:docMk/>
-            <pc:sldMk cId="1202998437" sldId="258"/>
-            <ac:spMk id="4" creationId="{3CB62230-771B-FAE3-6266-AE36A336FA5B}"/>
-          </ac:spMkLst>
-        </pc:spChg>
       </pc:sldChg>
       <pc:sldChg chg="new del">
         <pc:chgData name="Skidmore, Ashley (Ashland)" userId="e9632adf-63fc-410d-b7a6-aeefea2bbcdf" providerId="ADAL" clId="{AF9B4E55-D5E8-4675-908F-49E3E051134E}" dt="2025-07-06T20:14:02.561" v="31" actId="680"/>
@@ -239,14 +217,6 @@
             <ac:spMk id="2" creationId="{A9B1E8F3-1ACE-A1FB-87C5-B73D7BB9EEC0}"/>
           </ac:spMkLst>
         </pc:spChg>
-        <pc:spChg chg="del">
-          <ac:chgData name="Skidmore, Ashley (Ashland)" userId="e9632adf-63fc-410d-b7a6-aeefea2bbcdf" providerId="ADAL" clId="{AF9B4E55-D5E8-4675-908F-49E3E051134E}" dt="2025-07-06T20:15:55.772" v="115" actId="478"/>
-          <ac:spMkLst>
-            <pc:docMk/>
-            <pc:sldMk cId="3412969806" sldId="259"/>
-            <ac:spMk id="3" creationId="{EFF8A02B-064D-9F28-F0F7-3724198526DA}"/>
-          </ac:spMkLst>
-        </pc:spChg>
       </pc:sldChg>
       <pc:sldChg chg="addSp delSp modSp new mod">
         <pc:chgData name="Skidmore, Ashley (Ashland)" userId="e9632adf-63fc-410d-b7a6-aeefea2bbcdf" providerId="ADAL" clId="{AF9B4E55-D5E8-4675-908F-49E3E051134E}" dt="2025-07-06T20:19:16.502" v="431" actId="20577"/>
@@ -260,14 +230,6 @@
             <pc:docMk/>
             <pc:sldMk cId="3463863908" sldId="260"/>
             <ac:spMk id="2" creationId="{CFB8ACFA-BA59-968E-1D20-0851563311D7}"/>
-          </ac:spMkLst>
-        </pc:spChg>
-        <pc:spChg chg="del">
-          <ac:chgData name="Skidmore, Ashley (Ashland)" userId="e9632adf-63fc-410d-b7a6-aeefea2bbcdf" providerId="ADAL" clId="{AF9B4E55-D5E8-4675-908F-49E3E051134E}" dt="2025-07-06T20:16:46.097" v="117" actId="931"/>
-          <ac:spMkLst>
-            <pc:docMk/>
-            <pc:sldMk cId="3463863908" sldId="260"/>
-            <ac:spMk id="3" creationId="{1E96E52E-34D5-9006-BBC2-FAC35DB8F057}"/>
           </ac:spMkLst>
         </pc:spChg>
         <pc:spChg chg="mod">
@@ -301,14 +263,6 @@
             <ac:spMk id="2" creationId="{9CCAC554-F176-418F-EB7D-EB772EDDA4A9}"/>
           </ac:spMkLst>
         </pc:spChg>
-        <pc:spChg chg="add del">
-          <ac:chgData name="Skidmore, Ashley (Ashland)" userId="e9632adf-63fc-410d-b7a6-aeefea2bbcdf" providerId="ADAL" clId="{AF9B4E55-D5E8-4675-908F-49E3E051134E}" dt="2025-07-06T20:21:48.752" v="513" actId="478"/>
-          <ac:spMkLst>
-            <pc:docMk/>
-            <pc:sldMk cId="3969537788" sldId="261"/>
-            <ac:spMk id="3" creationId="{B28085E5-BDA1-D601-FD13-8FCEDBC0DB0C}"/>
-          </ac:spMkLst>
-        </pc:spChg>
         <pc:spChg chg="mod">
           <ac:chgData name="Skidmore, Ashley (Ashland)" userId="e9632adf-63fc-410d-b7a6-aeefea2bbcdf" providerId="ADAL" clId="{AF9B4E55-D5E8-4675-908F-49E3E051134E}" dt="2025-07-06T20:20:49.672" v="503" actId="20577"/>
           <ac:spMkLst>
@@ -317,62 +271,6 @@
             <ac:spMk id="4" creationId="{2D6848AE-C654-5013-DAA6-BC282785C56E}"/>
           </ac:spMkLst>
         </pc:spChg>
-        <pc:spChg chg="add del">
-          <ac:chgData name="Skidmore, Ashley (Ashland)" userId="e9632adf-63fc-410d-b7a6-aeefea2bbcdf" providerId="ADAL" clId="{AF9B4E55-D5E8-4675-908F-49E3E051134E}" dt="2025-07-06T20:20:11.592" v="465" actId="26606"/>
-          <ac:spMkLst>
-            <pc:docMk/>
-            <pc:sldMk cId="3969537788" sldId="261"/>
-            <ac:spMk id="11" creationId="{DBC6133C-0615-4CE4-9132-37E609A9BDFA}"/>
-          </ac:spMkLst>
-        </pc:spChg>
-        <pc:spChg chg="add del">
-          <ac:chgData name="Skidmore, Ashley (Ashland)" userId="e9632adf-63fc-410d-b7a6-aeefea2bbcdf" providerId="ADAL" clId="{AF9B4E55-D5E8-4675-908F-49E3E051134E}" dt="2025-07-06T20:20:11.592" v="465" actId="26606"/>
-          <ac:spMkLst>
-            <pc:docMk/>
-            <pc:sldMk cId="3969537788" sldId="261"/>
-            <ac:spMk id="13" creationId="{169CC832-2974-4E8D-90ED-3E2941BA7336}"/>
-          </ac:spMkLst>
-        </pc:spChg>
-        <pc:spChg chg="add del">
-          <ac:chgData name="Skidmore, Ashley (Ashland)" userId="e9632adf-63fc-410d-b7a6-aeefea2bbcdf" providerId="ADAL" clId="{AF9B4E55-D5E8-4675-908F-49E3E051134E}" dt="2025-07-06T20:20:11.592" v="465" actId="26606"/>
-          <ac:spMkLst>
-            <pc:docMk/>
-            <pc:sldMk cId="3969537788" sldId="261"/>
-            <ac:spMk id="15" creationId="{55222F96-971A-4F90-B841-6BAB416C7AC1}"/>
-          </ac:spMkLst>
-        </pc:spChg>
-        <pc:spChg chg="add del">
-          <ac:chgData name="Skidmore, Ashley (Ashland)" userId="e9632adf-63fc-410d-b7a6-aeefea2bbcdf" providerId="ADAL" clId="{AF9B4E55-D5E8-4675-908F-49E3E051134E}" dt="2025-07-06T20:20:11.592" v="465" actId="26606"/>
-          <ac:spMkLst>
-            <pc:docMk/>
-            <pc:sldMk cId="3969537788" sldId="261"/>
-            <ac:spMk id="17" creationId="{08980754-6F4B-43C9-B9BE-127B6BED6586}"/>
-          </ac:spMkLst>
-        </pc:spChg>
-        <pc:spChg chg="add del">
-          <ac:chgData name="Skidmore, Ashley (Ashland)" userId="e9632adf-63fc-410d-b7a6-aeefea2bbcdf" providerId="ADAL" clId="{AF9B4E55-D5E8-4675-908F-49E3E051134E}" dt="2025-07-06T20:20:11.592" v="465" actId="26606"/>
-          <ac:spMkLst>
-            <pc:docMk/>
-            <pc:sldMk cId="3969537788" sldId="261"/>
-            <ac:spMk id="19" creationId="{2C1BBA94-3F40-40AA-8BB9-E69E25E537C1}"/>
-          </ac:spMkLst>
-        </pc:spChg>
-        <pc:picChg chg="add mod ord">
-          <ac:chgData name="Skidmore, Ashley (Ashland)" userId="e9632adf-63fc-410d-b7a6-aeefea2bbcdf" providerId="ADAL" clId="{AF9B4E55-D5E8-4675-908F-49E3E051134E}" dt="2025-07-06T20:20:22.769" v="469" actId="931"/>
-          <ac:picMkLst>
-            <pc:docMk/>
-            <pc:sldMk cId="3969537788" sldId="261"/>
-            <ac:picMk id="6" creationId="{535DD728-B19F-4FB2-071F-C288B00D76B6}"/>
-          </ac:picMkLst>
-        </pc:picChg>
-        <pc:picChg chg="add mod">
-          <ac:chgData name="Skidmore, Ashley (Ashland)" userId="e9632adf-63fc-410d-b7a6-aeefea2bbcdf" providerId="ADAL" clId="{AF9B4E55-D5E8-4675-908F-49E3E051134E}" dt="2025-07-06T20:21:44.410" v="512" actId="931"/>
-          <ac:picMkLst>
-            <pc:docMk/>
-            <pc:sldMk cId="3969537788" sldId="261"/>
-            <ac:picMk id="8" creationId="{39403EB4-7634-5404-B9FC-15B7DE18E3EF}"/>
-          </ac:picMkLst>
-        </pc:picChg>
         <pc:picChg chg="add mod">
           <ac:chgData name="Skidmore, Ashley (Ashland)" userId="e9632adf-63fc-410d-b7a6-aeefea2bbcdf" providerId="ADAL" clId="{AF9B4E55-D5E8-4675-908F-49E3E051134E}" dt="2025-07-06T20:22:27" v="559" actId="14100"/>
           <ac:picMkLst>
@@ -396,14 +294,6 @@
             <ac:spMk id="2" creationId="{10CC9DC6-5845-F17F-DDD0-85B751E2005D}"/>
           </ac:spMkLst>
         </pc:spChg>
-        <pc:spChg chg="del">
-          <ac:chgData name="Skidmore, Ashley (Ashland)" userId="e9632adf-63fc-410d-b7a6-aeefea2bbcdf" providerId="ADAL" clId="{AF9B4E55-D5E8-4675-908F-49E3E051134E}" dt="2025-07-06T20:25:59.167" v="866" actId="931"/>
-          <ac:spMkLst>
-            <pc:docMk/>
-            <pc:sldMk cId="2372287732" sldId="262"/>
-            <ac:spMk id="3" creationId="{001D15E2-26E2-7ECA-6FB4-E338EA544B63}"/>
-          </ac:spMkLst>
-        </pc:spChg>
         <pc:spChg chg="mod">
           <ac:chgData name="Skidmore, Ashley (Ashland)" userId="e9632adf-63fc-410d-b7a6-aeefea2bbcdf" providerId="ADAL" clId="{AF9B4E55-D5E8-4675-908F-49E3E051134E}" dt="2025-07-06T20:25:48.649" v="865" actId="1036"/>
           <ac:spMkLst>
@@ -412,22 +302,6 @@
             <ac:spMk id="4" creationId="{304FD29F-7AD7-3174-EC4F-9BDAEE88D2A5}"/>
           </ac:spMkLst>
         </pc:spChg>
-        <pc:spChg chg="add del mod">
-          <ac:chgData name="Skidmore, Ashley (Ashland)" userId="e9632adf-63fc-410d-b7a6-aeefea2bbcdf" providerId="ADAL" clId="{AF9B4E55-D5E8-4675-908F-49E3E051134E}" dt="2025-07-06T20:26:09.265" v="870" actId="478"/>
-          <ac:spMkLst>
-            <pc:docMk/>
-            <pc:sldMk cId="2372287732" sldId="262"/>
-            <ac:spMk id="8" creationId="{6B02CEFE-6B01-657B-266E-B745CD7201B1}"/>
-          </ac:spMkLst>
-        </pc:spChg>
-        <pc:picChg chg="add del mod">
-          <ac:chgData name="Skidmore, Ashley (Ashland)" userId="e9632adf-63fc-410d-b7a6-aeefea2bbcdf" providerId="ADAL" clId="{AF9B4E55-D5E8-4675-908F-49E3E051134E}" dt="2025-07-06T20:26:06.251" v="869" actId="478"/>
-          <ac:picMkLst>
-            <pc:docMk/>
-            <pc:sldMk cId="2372287732" sldId="262"/>
-            <ac:picMk id="6" creationId="{10199B65-5242-A648-93FB-92B7829B7A51}"/>
-          </ac:picMkLst>
-        </pc:picChg>
         <pc:picChg chg="add mod">
           <ac:chgData name="Skidmore, Ashley (Ashland)" userId="e9632adf-63fc-410d-b7a6-aeefea2bbcdf" providerId="ADAL" clId="{AF9B4E55-D5E8-4675-908F-49E3E051134E}" dt="2025-07-06T20:26:34.768" v="926" actId="14100"/>
           <ac:picMkLst>
@@ -451,14 +325,6 @@
             <ac:spMk id="2" creationId="{95B27902-DA23-1D54-041F-641AB3A5375C}"/>
           </ac:spMkLst>
         </pc:spChg>
-        <pc:spChg chg="del">
-          <ac:chgData name="Skidmore, Ashley (Ashland)" userId="e9632adf-63fc-410d-b7a6-aeefea2bbcdf" providerId="ADAL" clId="{AF9B4E55-D5E8-4675-908F-49E3E051134E}" dt="2025-07-06T20:27:58.418" v="990" actId="478"/>
-          <ac:spMkLst>
-            <pc:docMk/>
-            <pc:sldMk cId="2289412193" sldId="263"/>
-            <ac:spMk id="3" creationId="{E5240B7F-3183-242A-66CE-916900B10342}"/>
-          </ac:spMkLst>
-        </pc:spChg>
       </pc:sldChg>
       <pc:sldChg chg="modSp new del mod">
         <pc:chgData name="Skidmore, Ashley (Ashland)" userId="e9632adf-63fc-410d-b7a6-aeefea2bbcdf" providerId="ADAL" clId="{AF9B4E55-D5E8-4675-908F-49E3E051134E}" dt="2025-07-06T20:27:27.184" v="959" actId="680"/>
@@ -466,14 +332,6 @@
           <pc:docMk/>
           <pc:sldMk cId="2839551877" sldId="263"/>
         </pc:sldMkLst>
-        <pc:spChg chg="mod">
-          <ac:chgData name="Skidmore, Ashley (Ashland)" userId="e9632adf-63fc-410d-b7a6-aeefea2bbcdf" providerId="ADAL" clId="{AF9B4E55-D5E8-4675-908F-49E3E051134E}" dt="2025-07-06T20:27:25.802" v="958" actId="20577"/>
-          <ac:spMkLst>
-            <pc:docMk/>
-            <pc:sldMk cId="2839551877" sldId="263"/>
-            <ac:spMk id="3" creationId="{FDE888EB-14AC-B209-005E-6CF00E01D3F8}"/>
-          </ac:spMkLst>
-        </pc:spChg>
       </pc:sldChg>
       <pc:sldChg chg="new del">
         <pc:chgData name="Skidmore, Ashley (Ashland)" userId="e9632adf-63fc-410d-b7a6-aeefea2bbcdf" providerId="ADAL" clId="{AF9B4E55-D5E8-4675-908F-49E3E051134E}" dt="2025-07-06T20:27:43.812" v="961" actId="680"/>
@@ -506,13 +364,13 @@
         </pc:spChg>
       </pc:sldChg>
       <pc:sldChg chg="modSp add mod">
-        <pc:chgData name="Skidmore, Ashley (Ashland)" userId="e9632adf-63fc-410d-b7a6-aeefea2bbcdf" providerId="ADAL" clId="{AF9B4E55-D5E8-4675-908F-49E3E051134E}" dt="2025-07-06T20:30:23.321" v="1216" actId="20577"/>
+        <pc:chgData name="Skidmore, Ashley (Ashland)" userId="e9632adf-63fc-410d-b7a6-aeefea2bbcdf" providerId="ADAL" clId="{AF9B4E55-D5E8-4675-908F-49E3E051134E}" dt="2025-07-10T21:43:11.585" v="2003" actId="20577"/>
         <pc:sldMkLst>
           <pc:docMk/>
           <pc:sldMk cId="2069388411" sldId="265"/>
         </pc:sldMkLst>
         <pc:spChg chg="mod">
-          <ac:chgData name="Skidmore, Ashley (Ashland)" userId="e9632adf-63fc-410d-b7a6-aeefea2bbcdf" providerId="ADAL" clId="{AF9B4E55-D5E8-4675-908F-49E3E051134E}" dt="2025-07-06T20:30:17.509" v="1194" actId="20577"/>
+          <ac:chgData name="Skidmore, Ashley (Ashland)" userId="e9632adf-63fc-410d-b7a6-aeefea2bbcdf" providerId="ADAL" clId="{AF9B4E55-D5E8-4675-908F-49E3E051134E}" dt="2025-07-10T21:43:11.585" v="2003" actId="20577"/>
           <ac:spMkLst>
             <pc:docMk/>
             <pc:sldMk cId="2069388411" sldId="265"/>
@@ -520,7 +378,7 @@
           </ac:spMkLst>
         </pc:spChg>
         <pc:spChg chg="mod">
-          <ac:chgData name="Skidmore, Ashley (Ashland)" userId="e9632adf-63fc-410d-b7a6-aeefea2bbcdf" providerId="ADAL" clId="{AF9B4E55-D5E8-4675-908F-49E3E051134E}" dt="2025-07-06T20:30:23.321" v="1216" actId="20577"/>
+          <ac:chgData name="Skidmore, Ashley (Ashland)" userId="e9632adf-63fc-410d-b7a6-aeefea2bbcdf" providerId="ADAL" clId="{AF9B4E55-D5E8-4675-908F-49E3E051134E}" dt="2025-07-10T21:42:49.909" v="1969" actId="20577"/>
           <ac:spMkLst>
             <pc:docMk/>
             <pc:sldMk cId="2069388411" sldId="265"/>
@@ -528,14 +386,14 @@
           </ac:spMkLst>
         </pc:spChg>
       </pc:sldChg>
-      <pc:sldChg chg="modSp add mod">
-        <pc:chgData name="Skidmore, Ashley (Ashland)" userId="e9632adf-63fc-410d-b7a6-aeefea2bbcdf" providerId="ADAL" clId="{AF9B4E55-D5E8-4675-908F-49E3E051134E}" dt="2025-07-06T20:30:55.352" v="1254" actId="20577"/>
+      <pc:sldChg chg="modSp add mod ord">
+        <pc:chgData name="Skidmore, Ashley (Ashland)" userId="e9632adf-63fc-410d-b7a6-aeefea2bbcdf" providerId="ADAL" clId="{AF9B4E55-D5E8-4675-908F-49E3E051134E}" dt="2025-07-10T21:45:23.104" v="2323" actId="14100"/>
         <pc:sldMkLst>
           <pc:docMk/>
           <pc:sldMk cId="1106272256" sldId="266"/>
         </pc:sldMkLst>
         <pc:spChg chg="mod">
-          <ac:chgData name="Skidmore, Ashley (Ashland)" userId="e9632adf-63fc-410d-b7a6-aeefea2bbcdf" providerId="ADAL" clId="{AF9B4E55-D5E8-4675-908F-49E3E051134E}" dt="2025-07-06T20:30:55.352" v="1254" actId="20577"/>
+          <ac:chgData name="Skidmore, Ashley (Ashland)" userId="e9632adf-63fc-410d-b7a6-aeefea2bbcdf" providerId="ADAL" clId="{AF9B4E55-D5E8-4675-908F-49E3E051134E}" dt="2025-07-10T21:45:23.104" v="2323" actId="14100"/>
           <ac:spMkLst>
             <pc:docMk/>
             <pc:sldMk cId="1106272256" sldId="266"/>
@@ -543,7 +401,7 @@
           </ac:spMkLst>
         </pc:spChg>
         <pc:spChg chg="mod">
-          <ac:chgData name="Skidmore, Ashley (Ashland)" userId="e9632adf-63fc-410d-b7a6-aeefea2bbcdf" providerId="ADAL" clId="{AF9B4E55-D5E8-4675-908F-49E3E051134E}" dt="2025-07-06T20:30:42.072" v="1250" actId="20577"/>
+          <ac:chgData name="Skidmore, Ashley (Ashland)" userId="e9632adf-63fc-410d-b7a6-aeefea2bbcdf" providerId="ADAL" clId="{AF9B4E55-D5E8-4675-908F-49E3E051134E}" dt="2025-07-10T21:42:44.918" v="1967" actId="20577"/>
           <ac:spMkLst>
             <pc:docMk/>
             <pc:sldMk cId="1106272256" sldId="266"/>
@@ -573,6 +431,92 @@
             <ac:spMk id="3" creationId="{347CBF4D-7B01-B07E-0649-386333DC6582}"/>
           </ac:spMkLst>
         </pc:spChg>
+      </pc:sldChg>
+      <pc:sldChg chg="addSp delSp modSp new mod">
+        <pc:chgData name="Skidmore, Ashley (Ashland)" userId="e9632adf-63fc-410d-b7a6-aeefea2bbcdf" providerId="ADAL" clId="{AF9B4E55-D5E8-4675-908F-49E3E051134E}" dt="2025-07-10T21:51:43.990" v="2492" actId="1035"/>
+        <pc:sldMkLst>
+          <pc:docMk/>
+          <pc:sldMk cId="1215546209" sldId="268"/>
+        </pc:sldMkLst>
+        <pc:spChg chg="mod">
+          <ac:chgData name="Skidmore, Ashley (Ashland)" userId="e9632adf-63fc-410d-b7a6-aeefea2bbcdf" providerId="ADAL" clId="{AF9B4E55-D5E8-4675-908F-49E3E051134E}" dt="2025-07-10T21:45:56.226" v="2366" actId="20577"/>
+          <ac:spMkLst>
+            <pc:docMk/>
+            <pc:sldMk cId="1215546209" sldId="268"/>
+            <ac:spMk id="2" creationId="{43C6A1D0-B05A-104D-3223-DDEE6E475B99}"/>
+          </ac:spMkLst>
+        </pc:spChg>
+        <pc:spChg chg="del">
+          <ac:chgData name="Skidmore, Ashley (Ashland)" userId="e9632adf-63fc-410d-b7a6-aeefea2bbcdf" providerId="ADAL" clId="{AF9B4E55-D5E8-4675-908F-49E3E051134E}" dt="2025-07-10T21:50:57.480" v="2436" actId="931"/>
+          <ac:spMkLst>
+            <pc:docMk/>
+            <pc:sldMk cId="1215546209" sldId="268"/>
+            <ac:spMk id="3" creationId="{13157FF6-C2B3-DCA0-F89B-0396B52E046D}"/>
+          </ac:spMkLst>
+        </pc:spChg>
+        <pc:spChg chg="mod">
+          <ac:chgData name="Skidmore, Ashley (Ashland)" userId="e9632adf-63fc-410d-b7a6-aeefea2bbcdf" providerId="ADAL" clId="{AF9B4E55-D5E8-4675-908F-49E3E051134E}" dt="2025-07-10T21:50:47.390" v="2435" actId="20577"/>
+          <ac:spMkLst>
+            <pc:docMk/>
+            <pc:sldMk cId="1215546209" sldId="268"/>
+            <ac:spMk id="4" creationId="{EFC2DE03-BD56-D16D-CD3E-DDBC1344AEB3}"/>
+          </ac:spMkLst>
+        </pc:spChg>
+        <pc:spChg chg="add del mod">
+          <ac:chgData name="Skidmore, Ashley (Ashland)" userId="e9632adf-63fc-410d-b7a6-aeefea2bbcdf" providerId="ADAL" clId="{AF9B4E55-D5E8-4675-908F-49E3E051134E}" dt="2025-07-10T21:51:28.262" v="2441" actId="478"/>
+          <ac:spMkLst>
+            <pc:docMk/>
+            <pc:sldMk cId="1215546209" sldId="268"/>
+            <ac:spMk id="8" creationId="{C22292D8-AA78-1103-9B34-3FBA9B92782A}"/>
+          </ac:spMkLst>
+        </pc:spChg>
+        <pc:picChg chg="add del mod">
+          <ac:chgData name="Skidmore, Ashley (Ashland)" userId="e9632adf-63fc-410d-b7a6-aeefea2bbcdf" providerId="ADAL" clId="{AF9B4E55-D5E8-4675-908F-49E3E051134E}" dt="2025-07-10T21:51:07.836" v="2440" actId="478"/>
+          <ac:picMkLst>
+            <pc:docMk/>
+            <pc:sldMk cId="1215546209" sldId="268"/>
+            <ac:picMk id="6" creationId="{7511417E-81E8-9766-78C2-C6A21439D435}"/>
+          </ac:picMkLst>
+        </pc:picChg>
+        <pc:picChg chg="add mod">
+          <ac:chgData name="Skidmore, Ashley (Ashland)" userId="e9632adf-63fc-410d-b7a6-aeefea2bbcdf" providerId="ADAL" clId="{AF9B4E55-D5E8-4675-908F-49E3E051134E}" dt="2025-07-10T21:51:43.990" v="2492" actId="1035"/>
+          <ac:picMkLst>
+            <pc:docMk/>
+            <pc:sldMk cId="1215546209" sldId="268"/>
+            <ac:picMk id="10" creationId="{255C1B81-30CB-5045-BD56-2F3F3507A399}"/>
+          </ac:picMkLst>
+        </pc:picChg>
+      </pc:sldChg>
+      <pc:sldChg chg="addSp delSp modSp add mod ord">
+        <pc:chgData name="Skidmore, Ashley (Ashland)" userId="e9632adf-63fc-410d-b7a6-aeefea2bbcdf" providerId="ADAL" clId="{AF9B4E55-D5E8-4675-908F-49E3E051134E}" dt="2025-07-10T21:50:05.869" v="2430"/>
+        <pc:sldMkLst>
+          <pc:docMk/>
+          <pc:sldMk cId="3051523198" sldId="269"/>
+        </pc:sldMkLst>
+        <pc:spChg chg="del">
+          <ac:chgData name="Skidmore, Ashley (Ashland)" userId="e9632adf-63fc-410d-b7a6-aeefea2bbcdf" providerId="ADAL" clId="{AF9B4E55-D5E8-4675-908F-49E3E051134E}" dt="2025-07-10T21:49:34.505" v="2378" actId="478"/>
+          <ac:spMkLst>
+            <pc:docMk/>
+            <pc:sldMk cId="3051523198" sldId="269"/>
+            <ac:spMk id="3" creationId="{0B3F34E3-288C-B935-6878-BA3E1ECEEE59}"/>
+          </ac:spMkLst>
+        </pc:spChg>
+        <pc:spChg chg="mod">
+          <ac:chgData name="Skidmore, Ashley (Ashland)" userId="e9632adf-63fc-410d-b7a6-aeefea2bbcdf" providerId="ADAL" clId="{AF9B4E55-D5E8-4675-908F-49E3E051134E}" dt="2025-07-10T21:47:30.997" v="2377" actId="20577"/>
+          <ac:spMkLst>
+            <pc:docMk/>
+            <pc:sldMk cId="3051523198" sldId="269"/>
+            <ac:spMk id="4" creationId="{B053255F-5F7D-ABC8-9367-CDE17CBFFBA7}"/>
+          </ac:spMkLst>
+        </pc:spChg>
+        <pc:picChg chg="add mod">
+          <ac:chgData name="Skidmore, Ashley (Ashland)" userId="e9632adf-63fc-410d-b7a6-aeefea2bbcdf" providerId="ADAL" clId="{AF9B4E55-D5E8-4675-908F-49E3E051134E}" dt="2025-07-10T21:49:54.739" v="2428" actId="14100"/>
+          <ac:picMkLst>
+            <pc:docMk/>
+            <pc:sldMk cId="3051523198" sldId="269"/>
+            <ac:picMk id="6" creationId="{E1C2CF41-02C6-AAA5-6187-2CB6F387ACCA}"/>
+          </ac:picMkLst>
+        </pc:picChg>
       </pc:sldChg>
     </pc:docChg>
   </pc:docChgLst>
@@ -764,7 +708,7 @@
             <a:fld id="{7E1F66B9-56F5-4B42-AE20-E71E7BA58FDC}" type="datetimeFigureOut">
               <a:rPr lang="en-US" smtClean="0"/>
               <a:pPr/>
-              <a:t>7/6/2025</a:t>
+              <a:t>7/10/2025</a:t>
             </a:fld>
             <a:endParaRPr lang="en-US" dirty="0"/>
           </a:p>
@@ -1069,7 +1013,7 @@
             <a:fld id="{7E1F66B9-56F5-4B42-AE20-E71E7BA58FDC}" type="datetimeFigureOut">
               <a:rPr lang="en-US" smtClean="0"/>
               <a:pPr/>
-              <a:t>7/6/2025</a:t>
+              <a:t>7/10/2025</a:t>
             </a:fld>
             <a:endParaRPr lang="en-US" dirty="0"/>
           </a:p>
@@ -1379,7 +1323,7 @@
             <a:fld id="{7E1F66B9-56F5-4B42-AE20-E71E7BA58FDC}" type="datetimeFigureOut">
               <a:rPr lang="en-US" smtClean="0"/>
               <a:pPr/>
-              <a:t>7/6/2025</a:t>
+              <a:t>7/10/2025</a:t>
             </a:fld>
             <a:endParaRPr lang="en-US" dirty="0"/>
           </a:p>
@@ -1689,7 +1633,7 @@
             <a:fld id="{7E1F66B9-56F5-4B42-AE20-E71E7BA58FDC}" type="datetimeFigureOut">
               <a:rPr lang="en-US" smtClean="0"/>
               <a:pPr/>
-              <a:t>7/6/2025</a:t>
+              <a:t>7/10/2025</a:t>
             </a:fld>
             <a:endParaRPr lang="en-US" dirty="0"/>
           </a:p>
@@ -2025,7 +1969,7 @@
             <a:fld id="{7E1F66B9-56F5-4B42-AE20-E71E7BA58FDC}" type="datetimeFigureOut">
               <a:rPr lang="en-US" smtClean="0"/>
               <a:pPr/>
-              <a:t>7/6/2025</a:t>
+              <a:t>7/10/2025</a:t>
             </a:fld>
             <a:endParaRPr lang="en-US" dirty="0"/>
           </a:p>
@@ -2476,7 +2420,7 @@
             <a:fld id="{7E1F66B9-56F5-4B42-AE20-E71E7BA58FDC}" type="datetimeFigureOut">
               <a:rPr lang="en-US" smtClean="0"/>
               <a:pPr/>
-              <a:t>7/6/2025</a:t>
+              <a:t>7/10/2025</a:t>
             </a:fld>
             <a:endParaRPr lang="en-US" dirty="0"/>
           </a:p>
@@ -3040,7 +2984,7 @@
             <a:fld id="{7E1F66B9-56F5-4B42-AE20-E71E7BA58FDC}" type="datetimeFigureOut">
               <a:rPr lang="en-US" smtClean="0"/>
               <a:pPr/>
-              <a:t>7/6/2025</a:t>
+              <a:t>7/10/2025</a:t>
             </a:fld>
             <a:endParaRPr lang="en-US" dirty="0"/>
           </a:p>
@@ -3246,7 +3190,7 @@
             <a:fld id="{7E1F66B9-56F5-4B42-AE20-E71E7BA58FDC}" type="datetimeFigureOut">
               <a:rPr lang="en-US" smtClean="0"/>
               <a:pPr/>
-              <a:t>7/6/2025</a:t>
+              <a:t>7/10/2025</a:t>
             </a:fld>
             <a:endParaRPr lang="en-US" dirty="0"/>
           </a:p>
@@ -3414,7 +3358,7 @@
             <a:fld id="{7E1F66B9-56F5-4B42-AE20-E71E7BA58FDC}" type="datetimeFigureOut">
               <a:rPr lang="en-US" smtClean="0"/>
               <a:pPr/>
-              <a:t>7/6/2025</a:t>
+              <a:t>7/10/2025</a:t>
             </a:fld>
             <a:endParaRPr lang="en-US" dirty="0"/>
           </a:p>
@@ -3813,7 +3757,7 @@
             <a:fld id="{7E1F66B9-56F5-4B42-AE20-E71E7BA58FDC}" type="datetimeFigureOut">
               <a:rPr lang="en-US" smtClean="0"/>
               <a:pPr/>
-              <a:t>7/6/2025</a:t>
+              <a:t>7/10/2025</a:t>
             </a:fld>
             <a:endParaRPr lang="en-US" dirty="0"/>
           </a:p>
@@ -4174,7 +4118,7 @@
             <a:fld id="{7E1F66B9-56F5-4B42-AE20-E71E7BA58FDC}" type="datetimeFigureOut">
               <a:rPr lang="en-US" smtClean="0"/>
               <a:pPr/>
-              <a:t>7/6/2025</a:t>
+              <a:t>7/10/2025</a:t>
             </a:fld>
             <a:endParaRPr lang="en-US" dirty="0"/>
           </a:p>
@@ -4443,7 +4387,7 @@
           <a:p>
             <a:fld id="{7E1F66B9-56F5-4B42-AE20-E71E7BA58FDC}" type="datetimeFigureOut">
               <a:rPr lang="en-US" smtClean="0"/>
-              <a:t>7/6/2025</a:t>
+              <a:t>7/10/2025</a:t>
             </a:fld>
             <a:endParaRPr lang="en-US" dirty="0"/>
           </a:p>
@@ -4941,7 +4885,7 @@
         <p:cNvPr id="1" name="">
           <a:extLst>
             <a:ext uri="{FF2B5EF4-FFF2-40B4-BE49-F238E27FC236}">
-              <a16:creationId xmlns:a16="http://schemas.microsoft.com/office/drawing/2014/main" id="{7639BA3C-0A7A-E607-6ABD-3552A64053EC}"/>
+              <a16:creationId xmlns:a16="http://schemas.microsoft.com/office/drawing/2014/main" id="{A7015037-5C98-E9E0-1DB1-2B0AB6AAA7C5}"/>
             </a:ext>
           </a:extLst>
         </p:cNvPr>
@@ -4961,7 +4905,7 @@
           <p:cNvPr id="2" name="Text Placeholder 1">
             <a:extLst>
               <a:ext uri="{FF2B5EF4-FFF2-40B4-BE49-F238E27FC236}">
-                <a16:creationId xmlns:a16="http://schemas.microsoft.com/office/drawing/2014/main" id="{318383E4-A649-2F64-EEFE-1610BDC2DF52}"/>
+                <a16:creationId xmlns:a16="http://schemas.microsoft.com/office/drawing/2014/main" id="{A19204D9-5BDC-CC39-BBE0-698259DCAEAC}"/>
               </a:ext>
             </a:extLst>
           </p:cNvPr>
@@ -4974,51 +4918,53 @@
         </p:nvSpPr>
         <p:spPr>
           <a:xfrm>
-            <a:off x="955040" y="3346409"/>
-            <a:ext cx="10392410" cy="1500187"/>
+            <a:off x="955040" y="3200400"/>
+            <a:ext cx="10392410" cy="1751161"/>
+          </a:xfrm>
+        </p:spPr>
+        <p:txBody>
+          <a:bodyPr>
+            <a:normAutofit/>
+          </a:bodyPr>
+          <a:lstStyle/>
+          <a:p>
+            <a:pPr lvl="0"/>
+            <a:r>
+              <a:rPr lang="en-US" dirty="0"/>
+              <a:t>Some individuals were dropped during the merge of ACS housing and demographic data because their serial numbers were not found in the housing dataset. This likely reflects missing or excluded housing data for certain household, such as those in institutional settings.</a:t>
+            </a:r>
+          </a:p>
+        </p:txBody>
+      </p:sp>
+      <p:sp>
+        <p:nvSpPr>
+          <p:cNvPr id="3" name="Title 2">
+            <a:extLst>
+              <a:ext uri="{FF2B5EF4-FFF2-40B4-BE49-F238E27FC236}">
+                <a16:creationId xmlns:a16="http://schemas.microsoft.com/office/drawing/2014/main" id="{77A4B671-E229-3DE4-4B24-39A0DE8CE290}"/>
+              </a:ext>
+            </a:extLst>
+          </p:cNvPr>
+          <p:cNvSpPr>
+            <a:spLocks noGrp="1"/>
+          </p:cNvSpPr>
+          <p:nvPr>
+            <p:ph type="title"/>
+          </p:nvPr>
+        </p:nvSpPr>
+        <p:spPr>
+          <a:xfrm>
+            <a:off x="955040" y="430239"/>
+            <a:ext cx="10392410" cy="2426833"/>
           </a:xfrm>
         </p:spPr>
         <p:txBody>
           <a:bodyPr/>
           <a:lstStyle/>
           <a:p>
-            <a:pPr lvl="0"/>
             <a:r>
               <a:rPr lang="en-US" dirty="0"/>
-              <a:t>Although the Census dataset is large, limiting the analysis to Kentucky left a sample of 504 likely incarcerated individuals, which restricts regional or subgroup analysis.</a:t>
-            </a:r>
-          </a:p>
-        </p:txBody>
-      </p:sp>
-      <p:sp>
-        <p:nvSpPr>
-          <p:cNvPr id="3" name="Title 2">
-            <a:extLst>
-              <a:ext uri="{FF2B5EF4-FFF2-40B4-BE49-F238E27FC236}">
-                <a16:creationId xmlns:a16="http://schemas.microsoft.com/office/drawing/2014/main" id="{A940CD6B-8DDC-C17B-340A-0BA58689AAA0}"/>
-              </a:ext>
-            </a:extLst>
-          </p:cNvPr>
-          <p:cNvSpPr>
-            <a:spLocks noGrp="1"/>
-          </p:cNvSpPr>
-          <p:nvPr>
-            <p:ph type="title"/>
-          </p:nvPr>
-        </p:nvSpPr>
-        <p:spPr>
-          <a:xfrm>
-            <a:off x="955040" y="430239"/>
-            <a:ext cx="10392410" cy="2426833"/>
-          </a:xfrm>
-        </p:spPr>
-        <p:txBody>
-          <a:bodyPr/>
-          <a:lstStyle/>
-          <a:p>
-            <a:r>
-              <a:rPr lang="en-US" dirty="0"/>
-              <a:t>Data Issue #2: Sample Size</a:t>
+              <a:t>Data Issue #2: Combining Datasets</a:t>
             </a:r>
           </a:p>
         </p:txBody>
@@ -5026,7 +4972,7 @@
     </p:spTree>
     <p:extLst>
       <p:ext uri="{BB962C8B-B14F-4D97-AF65-F5344CB8AC3E}">
-        <p14:creationId xmlns:p14="http://schemas.microsoft.com/office/powerpoint/2010/main" val="2069388411"/>
+        <p14:creationId xmlns:p14="http://schemas.microsoft.com/office/powerpoint/2010/main" val="1106272256"/>
       </p:ext>
     </p:extLst>
   </p:cSld>
@@ -5044,7 +4990,7 @@
         <p:cNvPr id="1" name="">
           <a:extLst>
             <a:ext uri="{FF2B5EF4-FFF2-40B4-BE49-F238E27FC236}">
-              <a16:creationId xmlns:a16="http://schemas.microsoft.com/office/drawing/2014/main" id="{A7015037-5C98-E9E0-1DB1-2B0AB6AAA7C5}"/>
+              <a16:creationId xmlns:a16="http://schemas.microsoft.com/office/drawing/2014/main" id="{7639BA3C-0A7A-E607-6ABD-3552A64053EC}"/>
             </a:ext>
           </a:extLst>
         </p:cNvPr>
@@ -5064,7 +5010,7 @@
           <p:cNvPr id="2" name="Text Placeholder 1">
             <a:extLst>
               <a:ext uri="{FF2B5EF4-FFF2-40B4-BE49-F238E27FC236}">
-                <a16:creationId xmlns:a16="http://schemas.microsoft.com/office/drawing/2014/main" id="{A19204D9-5BDC-CC39-BBE0-698259DCAEAC}"/>
+                <a16:creationId xmlns:a16="http://schemas.microsoft.com/office/drawing/2014/main" id="{318383E4-A649-2F64-EEFE-1610BDC2DF52}"/>
               </a:ext>
             </a:extLst>
           </p:cNvPr>
@@ -5082,15 +5028,13 @@
           </a:xfrm>
         </p:spPr>
         <p:txBody>
-          <a:bodyPr>
-            <a:normAutofit fontScale="92500"/>
-          </a:bodyPr>
+          <a:bodyPr/>
           <a:lstStyle/>
           <a:p>
             <a:pPr lvl="0"/>
             <a:r>
               <a:rPr lang="en-US" dirty="0"/>
-              <a:t>The personal and housing datasets from the Census had to be joined by household identifier. Because one household can include multiple people, and the housing data only includes one record per household, this join reduced the total number of people retained in the merged dataset.</a:t>
+              <a:t>Although the Census dataset is large, merging issues as well as limiting the analysis to Kentucky left a sample of 504 likely incarcerated individuals, which restricts regional or subgroup analysis.</a:t>
             </a:r>
           </a:p>
         </p:txBody>
@@ -5100,7 +5044,7 @@
           <p:cNvPr id="3" name="Title 2">
             <a:extLst>
               <a:ext uri="{FF2B5EF4-FFF2-40B4-BE49-F238E27FC236}">
-                <a16:creationId xmlns:a16="http://schemas.microsoft.com/office/drawing/2014/main" id="{77A4B671-E229-3DE4-4B24-39A0DE8CE290}"/>
+                <a16:creationId xmlns:a16="http://schemas.microsoft.com/office/drawing/2014/main" id="{A940CD6B-8DDC-C17B-340A-0BA58689AAA0}"/>
               </a:ext>
             </a:extLst>
           </p:cNvPr>
@@ -5123,7 +5067,7 @@
           <a:p>
             <a:r>
               <a:rPr lang="en-US" dirty="0"/>
-              <a:t>Data Issue #3: Combining Datasets</a:t>
+              <a:t>Data Issue #3: Sample Size</a:t>
             </a:r>
           </a:p>
         </p:txBody>
@@ -5131,7 +5075,7 @@
     </p:spTree>
     <p:extLst>
       <p:ext uri="{BB962C8B-B14F-4D97-AF65-F5344CB8AC3E}">
-        <p14:creationId xmlns:p14="http://schemas.microsoft.com/office/powerpoint/2010/main" val="1106272256"/>
+        <p14:creationId xmlns:p14="http://schemas.microsoft.com/office/powerpoint/2010/main" val="2069388411"/>
       </p:ext>
     </p:extLst>
   </p:cSld>
@@ -5270,6 +5214,279 @@
     <p:extLst>
       <p:ext uri="{BB962C8B-B14F-4D97-AF65-F5344CB8AC3E}">
         <p14:creationId xmlns:p14="http://schemas.microsoft.com/office/powerpoint/2010/main" val="1781353271"/>
+      </p:ext>
+    </p:extLst>
+  </p:cSld>
+  <p:clrMapOvr>
+    <a:masterClrMapping/>
+  </p:clrMapOvr>
+</p:sld>
+</file>
+
+<file path=ppt/slides/slide13.xml><?xml version="1.0" encoding="utf-8"?>
+<p:sld xmlns:a="http://schemas.openxmlformats.org/drawingml/2006/main" xmlns:r="http://schemas.openxmlformats.org/officeDocument/2006/relationships" xmlns:p="http://schemas.openxmlformats.org/presentationml/2006/main">
+  <p:cSld>
+    <p:spTree>
+      <p:nvGrpSpPr>
+        <p:cNvPr id="1" name="">
+          <a:extLst>
+            <a:ext uri="{FF2B5EF4-FFF2-40B4-BE49-F238E27FC236}">
+              <a16:creationId xmlns:a16="http://schemas.microsoft.com/office/drawing/2014/main" id="{4AC3EF6B-5FE9-E70A-D694-89D0209B93C4}"/>
+            </a:ext>
+          </a:extLst>
+        </p:cNvPr>
+        <p:cNvGrpSpPr/>
+        <p:nvPr/>
+      </p:nvGrpSpPr>
+      <p:grpSpPr>
+        <a:xfrm>
+          <a:off x="0" y="0"/>
+          <a:ext cx="0" cy="0"/>
+          <a:chOff x="0" y="0"/>
+          <a:chExt cx="0" cy="0"/>
+        </a:xfrm>
+      </p:grpSpPr>
+      <p:sp>
+        <p:nvSpPr>
+          <p:cNvPr id="2" name="Title 1">
+            <a:extLst>
+              <a:ext uri="{FF2B5EF4-FFF2-40B4-BE49-F238E27FC236}">
+                <a16:creationId xmlns:a16="http://schemas.microsoft.com/office/drawing/2014/main" id="{6A2A24E3-40BE-B0E4-13D5-40259EAD5E58}"/>
+              </a:ext>
+            </a:extLst>
+          </p:cNvPr>
+          <p:cNvSpPr>
+            <a:spLocks noGrp="1"/>
+          </p:cNvSpPr>
+          <p:nvPr>
+            <p:ph type="title"/>
+          </p:nvPr>
+        </p:nvSpPr>
+        <p:spPr/>
+        <p:txBody>
+          <a:bodyPr/>
+          <a:lstStyle/>
+          <a:p>
+            <a:r>
+              <a:rPr lang="en-US" dirty="0"/>
+              <a:t>Additional Considerations and Applications</a:t>
+            </a:r>
+          </a:p>
+        </p:txBody>
+      </p:sp>
+      <p:sp>
+        <p:nvSpPr>
+          <p:cNvPr id="4" name="Text Placeholder 3">
+            <a:extLst>
+              <a:ext uri="{FF2B5EF4-FFF2-40B4-BE49-F238E27FC236}">
+                <a16:creationId xmlns:a16="http://schemas.microsoft.com/office/drawing/2014/main" id="{B053255F-5F7D-ABC8-9367-CDE17CBFFBA7}"/>
+              </a:ext>
+            </a:extLst>
+          </p:cNvPr>
+          <p:cNvSpPr>
+            <a:spLocks noGrp="1"/>
+          </p:cNvSpPr>
+          <p:nvPr>
+            <p:ph type="body" sz="half" idx="2"/>
+          </p:nvPr>
+        </p:nvSpPr>
+        <p:spPr/>
+        <p:txBody>
+          <a:bodyPr/>
+          <a:lstStyle/>
+          <a:p>
+            <a:r>
+              <a:rPr lang="en-US" dirty="0"/>
+              <a:t>For future projects, cleaned data from this project can also be used to explore the benefits of specific programs at Ashland Community and Technical College, especially those for which an Associate’s Degree is not strictly required but common and desirable. </a:t>
+            </a:r>
+          </a:p>
+          <a:p>
+            <a:endParaRPr lang="en-US" dirty="0"/>
+          </a:p>
+          <a:p>
+            <a:r>
+              <a:rPr lang="en-US" b="1" dirty="0"/>
+              <a:t>Example:</a:t>
+            </a:r>
+            <a:r>
+              <a:rPr lang="en-US" dirty="0"/>
+              <a:t> Healthcare Occupations Utilizing an Associate in Applied Science Degree</a:t>
+            </a:r>
+          </a:p>
+          <a:p>
+            <a:endParaRPr lang="en-US" dirty="0"/>
+          </a:p>
+        </p:txBody>
+      </p:sp>
+      <p:pic>
+        <p:nvPicPr>
+          <p:cNvPr id="6" name="Picture 5">
+            <a:extLst>
+              <a:ext uri="{FF2B5EF4-FFF2-40B4-BE49-F238E27FC236}">
+                <a16:creationId xmlns:a16="http://schemas.microsoft.com/office/drawing/2014/main" id="{E1C2CF41-02C6-AAA5-6187-2CB6F387ACCA}"/>
+              </a:ext>
+            </a:extLst>
+          </p:cNvPr>
+          <p:cNvPicPr>
+            <a:picLocks noChangeAspect="1"/>
+          </p:cNvPicPr>
+          <p:nvPr/>
+        </p:nvPicPr>
+        <p:blipFill>
+          <a:blip r:embed="rId2"/>
+          <a:stretch>
+            <a:fillRect/>
+          </a:stretch>
+        </p:blipFill>
+        <p:spPr>
+          <a:xfrm>
+            <a:off x="4772024" y="947391"/>
+            <a:ext cx="6580187" cy="4963218"/>
+          </a:xfrm>
+          <a:prstGeom prst="rect">
+            <a:avLst/>
+          </a:prstGeom>
+        </p:spPr>
+      </p:pic>
+    </p:spTree>
+    <p:extLst>
+      <p:ext uri="{BB962C8B-B14F-4D97-AF65-F5344CB8AC3E}">
+        <p14:creationId xmlns:p14="http://schemas.microsoft.com/office/powerpoint/2010/main" val="3051523198"/>
+      </p:ext>
+    </p:extLst>
+  </p:cSld>
+  <p:clrMapOvr>
+    <a:masterClrMapping/>
+  </p:clrMapOvr>
+</p:sld>
+</file>
+
+<file path=ppt/slides/slide14.xml><?xml version="1.0" encoding="utf-8"?>
+<p:sld xmlns:a="http://schemas.openxmlformats.org/drawingml/2006/main" xmlns:r="http://schemas.openxmlformats.org/officeDocument/2006/relationships" xmlns:p="http://schemas.openxmlformats.org/presentationml/2006/main">
+  <p:cSld>
+    <p:spTree>
+      <p:nvGrpSpPr>
+        <p:cNvPr id="1" name=""/>
+        <p:cNvGrpSpPr/>
+        <p:nvPr/>
+      </p:nvGrpSpPr>
+      <p:grpSpPr>
+        <a:xfrm>
+          <a:off x="0" y="0"/>
+          <a:ext cx="0" cy="0"/>
+          <a:chOff x="0" y="0"/>
+          <a:chExt cx="0" cy="0"/>
+        </a:xfrm>
+      </p:grpSpPr>
+      <p:sp>
+        <p:nvSpPr>
+          <p:cNvPr id="2" name="Title 1">
+            <a:extLst>
+              <a:ext uri="{FF2B5EF4-FFF2-40B4-BE49-F238E27FC236}">
+                <a16:creationId xmlns:a16="http://schemas.microsoft.com/office/drawing/2014/main" id="{43C6A1D0-B05A-104D-3223-DDEE6E475B99}"/>
+              </a:ext>
+            </a:extLst>
+          </p:cNvPr>
+          <p:cNvSpPr>
+            <a:spLocks noGrp="1"/>
+          </p:cNvSpPr>
+          <p:nvPr>
+            <p:ph type="title"/>
+          </p:nvPr>
+        </p:nvSpPr>
+        <p:spPr/>
+        <p:txBody>
+          <a:bodyPr/>
+          <a:lstStyle/>
+          <a:p>
+            <a:r>
+              <a:rPr lang="en-US" dirty="0"/>
+              <a:t>Additional Considerations and Applications</a:t>
+            </a:r>
+          </a:p>
+        </p:txBody>
+      </p:sp>
+      <p:sp>
+        <p:nvSpPr>
+          <p:cNvPr id="4" name="Text Placeholder 3">
+            <a:extLst>
+              <a:ext uri="{FF2B5EF4-FFF2-40B4-BE49-F238E27FC236}">
+                <a16:creationId xmlns:a16="http://schemas.microsoft.com/office/drawing/2014/main" id="{EFC2DE03-BD56-D16D-CD3E-DDBC1344AEB3}"/>
+              </a:ext>
+            </a:extLst>
+          </p:cNvPr>
+          <p:cNvSpPr>
+            <a:spLocks noGrp="1"/>
+          </p:cNvSpPr>
+          <p:nvPr>
+            <p:ph type="body" sz="half" idx="2"/>
+          </p:nvPr>
+        </p:nvSpPr>
+        <p:spPr/>
+        <p:txBody>
+          <a:bodyPr/>
+          <a:lstStyle/>
+          <a:p>
+            <a:r>
+              <a:rPr lang="en-US" dirty="0"/>
+              <a:t>The cleaned data from this project can also be used to explore the benefits of and need for potential occupational training programs ACTC does not already offer. </a:t>
+            </a:r>
+          </a:p>
+          <a:p>
+            <a:endParaRPr lang="en-US" dirty="0"/>
+          </a:p>
+          <a:p>
+            <a:r>
+              <a:rPr lang="en-US" b="1" dirty="0"/>
+              <a:t>**Example:**</a:t>
+            </a:r>
+            <a:r>
+              <a:rPr lang="en-US" dirty="0"/>
+              <a:t> Carpentry and Barbering</a:t>
+            </a:r>
+          </a:p>
+        </p:txBody>
+      </p:sp>
+      <p:pic>
+        <p:nvPicPr>
+          <p:cNvPr id="10" name="Picture 9" descr="A close-up of a computer screen&#10;&#10;AI-generated content may be incorrect.">
+            <a:extLst>
+              <a:ext uri="{FF2B5EF4-FFF2-40B4-BE49-F238E27FC236}">
+                <a16:creationId xmlns:a16="http://schemas.microsoft.com/office/drawing/2014/main" id="{255C1B81-30CB-5045-BD56-2F3F3507A399}"/>
+              </a:ext>
+            </a:extLst>
+          </p:cNvPr>
+          <p:cNvPicPr>
+            <a:picLocks noChangeAspect="1"/>
+          </p:cNvPicPr>
+          <p:nvPr/>
+        </p:nvPicPr>
+        <p:blipFill>
+          <a:blip r:embed="rId2">
+            <a:extLst>
+              <a:ext uri="{28A0092B-C50C-407E-A947-70E740481C1C}">
+                <a14:useLocalDpi xmlns:a14="http://schemas.microsoft.com/office/drawing/2010/main" val="0"/>
+              </a:ext>
+            </a:extLst>
+          </a:blip>
+          <a:stretch>
+            <a:fillRect/>
+          </a:stretch>
+        </p:blipFill>
+        <p:spPr>
+          <a:xfrm>
+            <a:off x="4772025" y="1443544"/>
+            <a:ext cx="6735788" cy="3374143"/>
+          </a:xfrm>
+          <a:prstGeom prst="rect">
+            <a:avLst/>
+          </a:prstGeom>
+        </p:spPr>
+      </p:pic>
+    </p:spTree>
+    <p:extLst>
+      <p:ext uri="{BB962C8B-B14F-4D97-AF65-F5344CB8AC3E}">
+        <p14:creationId xmlns:p14="http://schemas.microsoft.com/office/powerpoint/2010/main" val="1215546209"/>
       </p:ext>
     </p:extLst>
   </p:cSld>

</xml_diff>

<commit_message>
correcting discrepancies in Python and Tableau heatmaps and updating summary and presentation to reflect changes
</commit_message>
<xml_diff>
--- a/deliverables/project_presentation.pptx
+++ b/deliverables/project_presentation.pptx
@@ -125,6 +125,14 @@
 </p:presentation>
 </file>
 
+<file path=ppt/revisionInfo.xml><?xml version="1.0" encoding="utf-8"?>
+<p1510:revInfo xmlns:a="http://schemas.openxmlformats.org/drawingml/2006/main" xmlns:r="http://schemas.openxmlformats.org/officeDocument/2006/relationships" xmlns:p1510="http://schemas.microsoft.com/office/powerpoint/2015/10/main">
+  <p1510:revLst>
+    <p1510:client id="{AF9B4E55-D5E8-4675-908F-49E3E051134E}" v="1" dt="2025-07-28T18:18:31.266"/>
+  </p1510:revLst>
+</p1510:revInfo>
+</file>
+
 <file path=ppt/changesInfos/changesInfo1.xml><?xml version="1.0" encoding="utf-8"?>
 <pc:chgInfo xmlns:a="http://schemas.openxmlformats.org/drawingml/2006/main" xmlns:r="http://schemas.openxmlformats.org/officeDocument/2006/relationships" xmlns:ac="http://schemas.microsoft.com/office/drawing/2013/main/command" xmlns:pc="http://schemas.microsoft.com/office/powerpoint/2013/main/command">
   <pc:docChgLst>
@@ -169,7 +177,7 @@
   <pc:docChgLst>
     <pc:chgData name="Skidmore, Ashley (Ashland)" userId="e9632adf-63fc-410d-b7a6-aeefea2bbcdf" providerId="ADAL" clId="{AF9B4E55-D5E8-4675-908F-49E3E051134E}"/>
     <pc:docChg chg="undo custSel addSld delSld modSld sldOrd">
-      <pc:chgData name="Skidmore, Ashley (Ashland)" userId="e9632adf-63fc-410d-b7a6-aeefea2bbcdf" providerId="ADAL" clId="{AF9B4E55-D5E8-4675-908F-49E3E051134E}" dt="2025-07-10T21:51:43.990" v="2492" actId="1035"/>
+      <pc:chgData name="Skidmore, Ashley (Ashland)" userId="e9632adf-63fc-410d-b7a6-aeefea2bbcdf" providerId="ADAL" clId="{AF9B4E55-D5E8-4675-908F-49E3E051134E}" dt="2025-07-28T18:26:08.393" v="2947" actId="20577"/>
       <pc:docMkLst>
         <pc:docMk/>
       </pc:docMkLst>
@@ -312,7 +320,7 @@
         </pc:picChg>
       </pc:sldChg>
       <pc:sldChg chg="addSp delSp modSp new mod">
-        <pc:chgData name="Skidmore, Ashley (Ashland)" userId="e9632adf-63fc-410d-b7a6-aeefea2bbcdf" providerId="ADAL" clId="{AF9B4E55-D5E8-4675-908F-49E3E051134E}" dt="2025-07-06T20:26:34.768" v="926" actId="14100"/>
+        <pc:chgData name="Skidmore, Ashley (Ashland)" userId="e9632adf-63fc-410d-b7a6-aeefea2bbcdf" providerId="ADAL" clId="{AF9B4E55-D5E8-4675-908F-49E3E051134E}" dt="2025-07-28T18:20:21.737" v="2859" actId="20577"/>
         <pc:sldMkLst>
           <pc:docMk/>
           <pc:sldMk cId="2372287732" sldId="262"/>
@@ -326,7 +334,7 @@
           </ac:spMkLst>
         </pc:spChg>
         <pc:spChg chg="mod">
-          <ac:chgData name="Skidmore, Ashley (Ashland)" userId="e9632adf-63fc-410d-b7a6-aeefea2bbcdf" providerId="ADAL" clId="{AF9B4E55-D5E8-4675-908F-49E3E051134E}" dt="2025-07-06T20:25:48.649" v="865" actId="1036"/>
+          <ac:chgData name="Skidmore, Ashley (Ashland)" userId="e9632adf-63fc-410d-b7a6-aeefea2bbcdf" providerId="ADAL" clId="{AF9B4E55-D5E8-4675-908F-49E3E051134E}" dt="2025-07-28T18:20:21.737" v="2859" actId="20577"/>
           <ac:spMkLst>
             <pc:docMk/>
             <pc:sldMk cId="2372287732" sldId="262"/>
@@ -334,7 +342,7 @@
           </ac:spMkLst>
         </pc:spChg>
         <pc:picChg chg="add mod">
-          <ac:chgData name="Skidmore, Ashley (Ashland)" userId="e9632adf-63fc-410d-b7a6-aeefea2bbcdf" providerId="ADAL" clId="{AF9B4E55-D5E8-4675-908F-49E3E051134E}" dt="2025-07-06T20:26:34.768" v="926" actId="14100"/>
+          <ac:chgData name="Skidmore, Ashley (Ashland)" userId="e9632adf-63fc-410d-b7a6-aeefea2bbcdf" providerId="ADAL" clId="{AF9B4E55-D5E8-4675-908F-49E3E051134E}" dt="2025-07-28T18:18:54.944" v="2497" actId="14100"/>
           <ac:picMkLst>
             <pc:docMk/>
             <pc:sldMk cId="2372287732" sldId="262"/>
@@ -441,13 +449,13 @@
         </pc:spChg>
       </pc:sldChg>
       <pc:sldChg chg="modSp new mod">
-        <pc:chgData name="Skidmore, Ashley (Ashland)" userId="e9632adf-63fc-410d-b7a6-aeefea2bbcdf" providerId="ADAL" clId="{AF9B4E55-D5E8-4675-908F-49E3E051134E}" dt="2025-07-06T20:36:16.801" v="1954" actId="207"/>
+        <pc:chgData name="Skidmore, Ashley (Ashland)" userId="e9632adf-63fc-410d-b7a6-aeefea2bbcdf" providerId="ADAL" clId="{AF9B4E55-D5E8-4675-908F-49E3E051134E}" dt="2025-07-28T18:25:59.185" v="2943" actId="20577"/>
         <pc:sldMkLst>
           <pc:docMk/>
           <pc:sldMk cId="1781353271" sldId="267"/>
         </pc:sldMkLst>
         <pc:spChg chg="mod">
-          <ac:chgData name="Skidmore, Ashley (Ashland)" userId="e9632adf-63fc-410d-b7a6-aeefea2bbcdf" providerId="ADAL" clId="{AF9B4E55-D5E8-4675-908F-49E3E051134E}" dt="2025-07-06T20:36:16.801" v="1954" actId="207"/>
+          <ac:chgData name="Skidmore, Ashley (Ashland)" userId="e9632adf-63fc-410d-b7a6-aeefea2bbcdf" providerId="ADAL" clId="{AF9B4E55-D5E8-4675-908F-49E3E051134E}" dt="2025-07-28T18:25:59.185" v="2943" actId="20577"/>
           <ac:spMkLst>
             <pc:docMk/>
             <pc:sldMk cId="1781353271" sldId="267"/>
@@ -495,13 +503,13 @@
         </pc:picChg>
       </pc:sldChg>
       <pc:sldChg chg="addSp delSp modSp add mod ord">
-        <pc:chgData name="Skidmore, Ashley (Ashland)" userId="e9632adf-63fc-410d-b7a6-aeefea2bbcdf" providerId="ADAL" clId="{AF9B4E55-D5E8-4675-908F-49E3E051134E}" dt="2025-07-10T21:50:05.869" v="2430"/>
+        <pc:chgData name="Skidmore, Ashley (Ashland)" userId="e9632adf-63fc-410d-b7a6-aeefea2bbcdf" providerId="ADAL" clId="{AF9B4E55-D5E8-4675-908F-49E3E051134E}" dt="2025-07-28T18:26:08.393" v="2947" actId="20577"/>
         <pc:sldMkLst>
           <pc:docMk/>
           <pc:sldMk cId="3051523198" sldId="269"/>
         </pc:sldMkLst>
         <pc:spChg chg="mod">
-          <ac:chgData name="Skidmore, Ashley (Ashland)" userId="e9632adf-63fc-410d-b7a6-aeefea2bbcdf" providerId="ADAL" clId="{AF9B4E55-D5E8-4675-908F-49E3E051134E}" dt="2025-07-10T21:47:30.997" v="2377" actId="20577"/>
+          <ac:chgData name="Skidmore, Ashley (Ashland)" userId="e9632adf-63fc-410d-b7a6-aeefea2bbcdf" providerId="ADAL" clId="{AF9B4E55-D5E8-4675-908F-49E3E051134E}" dt="2025-07-28T18:26:08.393" v="2947" actId="20577"/>
           <ac:spMkLst>
             <pc:docMk/>
             <pc:sldMk cId="3051523198" sldId="269"/>
@@ -707,7 +715,7 @@
             <a:fld id="{7E1F66B9-56F5-4B42-AE20-E71E7BA58FDC}" type="datetimeFigureOut">
               <a:rPr lang="en-US" smtClean="0"/>
               <a:pPr/>
-              <a:t>7/15/2025</a:t>
+              <a:t>7/28/2025</a:t>
             </a:fld>
             <a:endParaRPr lang="en-US" dirty="0"/>
           </a:p>
@@ -1012,7 +1020,7 @@
             <a:fld id="{7E1F66B9-56F5-4B42-AE20-E71E7BA58FDC}" type="datetimeFigureOut">
               <a:rPr lang="en-US" smtClean="0"/>
               <a:pPr/>
-              <a:t>7/15/2025</a:t>
+              <a:t>7/28/2025</a:t>
             </a:fld>
             <a:endParaRPr lang="en-US" dirty="0"/>
           </a:p>
@@ -1322,7 +1330,7 @@
             <a:fld id="{7E1F66B9-56F5-4B42-AE20-E71E7BA58FDC}" type="datetimeFigureOut">
               <a:rPr lang="en-US" smtClean="0"/>
               <a:pPr/>
-              <a:t>7/15/2025</a:t>
+              <a:t>7/28/2025</a:t>
             </a:fld>
             <a:endParaRPr lang="en-US" dirty="0"/>
           </a:p>
@@ -1632,7 +1640,7 @@
             <a:fld id="{7E1F66B9-56F5-4B42-AE20-E71E7BA58FDC}" type="datetimeFigureOut">
               <a:rPr lang="en-US" smtClean="0"/>
               <a:pPr/>
-              <a:t>7/15/2025</a:t>
+              <a:t>7/28/2025</a:t>
             </a:fld>
             <a:endParaRPr lang="en-US" dirty="0"/>
           </a:p>
@@ -1968,7 +1976,7 @@
             <a:fld id="{7E1F66B9-56F5-4B42-AE20-E71E7BA58FDC}" type="datetimeFigureOut">
               <a:rPr lang="en-US" smtClean="0"/>
               <a:pPr/>
-              <a:t>7/15/2025</a:t>
+              <a:t>7/28/2025</a:t>
             </a:fld>
             <a:endParaRPr lang="en-US" dirty="0"/>
           </a:p>
@@ -2419,7 +2427,7 @@
             <a:fld id="{7E1F66B9-56F5-4B42-AE20-E71E7BA58FDC}" type="datetimeFigureOut">
               <a:rPr lang="en-US" smtClean="0"/>
               <a:pPr/>
-              <a:t>7/15/2025</a:t>
+              <a:t>7/28/2025</a:t>
             </a:fld>
             <a:endParaRPr lang="en-US" dirty="0"/>
           </a:p>
@@ -2983,7 +2991,7 @@
             <a:fld id="{7E1F66B9-56F5-4B42-AE20-E71E7BA58FDC}" type="datetimeFigureOut">
               <a:rPr lang="en-US" smtClean="0"/>
               <a:pPr/>
-              <a:t>7/15/2025</a:t>
+              <a:t>7/28/2025</a:t>
             </a:fld>
             <a:endParaRPr lang="en-US" dirty="0"/>
           </a:p>
@@ -3189,7 +3197,7 @@
             <a:fld id="{7E1F66B9-56F5-4B42-AE20-E71E7BA58FDC}" type="datetimeFigureOut">
               <a:rPr lang="en-US" smtClean="0"/>
               <a:pPr/>
-              <a:t>7/15/2025</a:t>
+              <a:t>7/28/2025</a:t>
             </a:fld>
             <a:endParaRPr lang="en-US" dirty="0"/>
           </a:p>
@@ -3357,7 +3365,7 @@
             <a:fld id="{7E1F66B9-56F5-4B42-AE20-E71E7BA58FDC}" type="datetimeFigureOut">
               <a:rPr lang="en-US" smtClean="0"/>
               <a:pPr/>
-              <a:t>7/15/2025</a:t>
+              <a:t>7/28/2025</a:t>
             </a:fld>
             <a:endParaRPr lang="en-US" dirty="0"/>
           </a:p>
@@ -3756,7 +3764,7 @@
             <a:fld id="{7E1F66B9-56F5-4B42-AE20-E71E7BA58FDC}" type="datetimeFigureOut">
               <a:rPr lang="en-US" smtClean="0"/>
               <a:pPr/>
-              <a:t>7/15/2025</a:t>
+              <a:t>7/28/2025</a:t>
             </a:fld>
             <a:endParaRPr lang="en-US" dirty="0"/>
           </a:p>
@@ -4117,7 +4125,7 @@
             <a:fld id="{7E1F66B9-56F5-4B42-AE20-E71E7BA58FDC}" type="datetimeFigureOut">
               <a:rPr lang="en-US" smtClean="0"/>
               <a:pPr/>
-              <a:t>7/15/2025</a:t>
+              <a:t>7/28/2025</a:t>
             </a:fld>
             <a:endParaRPr lang="en-US" dirty="0"/>
           </a:p>
@@ -4386,7 +4394,7 @@
           <a:p>
             <a:fld id="{7E1F66B9-56F5-4B42-AE20-E71E7BA58FDC}" type="datetimeFigureOut">
               <a:rPr lang="en-US" smtClean="0"/>
-              <a:t>7/15/2025</a:t>
+              <a:t>7/28/2025</a:t>
             </a:fld>
             <a:endParaRPr lang="en-US" dirty="0"/>
           </a:p>
@@ -5157,7 +5165,7 @@
                   <a:schemeClr val="bg1"/>
                 </a:solidFill>
               </a:rPr>
-              <a:t>Offering certificate and diploma programs</a:t>
+              <a:t>Offering terminal certificate, diploma, and associate’s degree programs</a:t>
             </a:r>
           </a:p>
           <a:p>
@@ -5171,7 +5179,7 @@
                   <a:schemeClr val="bg1"/>
                 </a:solidFill>
               </a:rPr>
-              <a:t>Offering associate degree programs leading to transfer to a bachelor degree-granting institution</a:t>
+              <a:t>Offering associate’s degree programs leading to transfer to bachelor’s degree-granting institutions</a:t>
             </a:r>
           </a:p>
         </p:txBody>
@@ -5296,7 +5304,23 @@
           <a:p>
             <a:r>
               <a:rPr lang="en-US" dirty="0"/>
-              <a:t>For future projects, cleaned data from this project can also be used to explore the benefits of specific programs at Ashland Community and Technical College, especially those for which an Associate’s Degree is not strictly required but common and desirable. </a:t>
+              <a:t>For future projects, cleaned data from this project can also be used to explore the benefits of specific programs at Ashland Community and Technical College, especially those for which </a:t>
+            </a:r>
+            <a:r>
+              <a:rPr lang="en-US"/>
+              <a:t>an associate’s </a:t>
+            </a:r>
+            <a:r>
+              <a:rPr lang="en-US" dirty="0"/>
+              <a:t>d</a:t>
+            </a:r>
+            <a:r>
+              <a:rPr lang="en-US"/>
+              <a:t>egree </a:t>
+            </a:r>
+            <a:r>
+              <a:rPr lang="en-US" dirty="0"/>
+              <a:t>is not strictly required but common and desirable. </a:t>
             </a:r>
           </a:p>
           <a:p>
@@ -6130,13 +6154,13 @@
         </p:spPr>
         <p:txBody>
           <a:bodyPr>
-            <a:normAutofit fontScale="92500" lnSpcReduction="10000"/>
+            <a:normAutofit fontScale="92500" lnSpcReduction="20000"/>
           </a:bodyPr>
           <a:lstStyle/>
           <a:p>
             <a:r>
               <a:rPr lang="en-US" dirty="0"/>
-              <a:t>While no high-demand, high-wage jobs were listed for an associate degree, postsecondary nondegree awards (such as certificates or diplomas) and bachelor degrees account for a significant number of employment opportunities.</a:t>
+              <a:t>In addition to the significant number of high-wage/high-demand occupations requiring an associate’s degree, postsecondary nondegree awards (such as certificates or diplomas) and bachelor’s degrees also account for a significant number of employment opportunities.</a:t>
             </a:r>
           </a:p>
           <a:p>
@@ -6155,7 +6179,7 @@
       </p:sp>
       <p:pic>
         <p:nvPicPr>
-          <p:cNvPr id="10" name="Picture 9" descr="A blue and white chart with text&#10;&#10;AI-generated content may be incorrect.">
+          <p:cNvPr id="10" name="Picture 9">
             <a:extLst>
               <a:ext uri="{FF2B5EF4-FFF2-40B4-BE49-F238E27FC236}">
                 <a16:creationId xmlns:a16="http://schemas.microsoft.com/office/drawing/2014/main" id="{63CAC5F9-B735-7A8E-6B25-CB9646B0580A}"/>
@@ -6175,14 +6199,13 @@
               </a:ext>
             </a:extLst>
           </a:blip>
-          <a:stretch>
-            <a:fillRect/>
-          </a:stretch>
+          <a:srcRect/>
+          <a:stretch/>
         </p:blipFill>
         <p:spPr>
           <a:xfrm>
-            <a:off x="4882101" y="1005835"/>
-            <a:ext cx="6367746" cy="4846330"/>
+            <a:off x="4882101" y="707366"/>
+            <a:ext cx="6470111" cy="4865298"/>
           </a:xfrm>
           <a:prstGeom prst="rect">
             <a:avLst/>

</xml_diff>